<commit_message>
fix robustness of task verification
</commit_message>
<xml_diff>
--- a/tasks/finalpool/fetch-wc-market-analysis-excel-ppt-email/groundtruth_workspace/Strategy_Presentation.pptx
+++ b/tasks/finalpool/fetch-wc-market-analysis-excel-ppt-email/groundtruth_workspace/Strategy_Presentation.pptx
@@ -3315,6 +3315,638 @@
           </a:p>
         </p:txBody>
       </p:sp>
+      <p:graphicFrame>
+        <p:nvGraphicFramePr>
+          <p:cNvPr id="4" name="Table 3"/>
+          <p:cNvGraphicFramePr>
+            <a:graphicFrameLocks noGrp="1"/>
+          </p:cNvGraphicFramePr>
+          <p:nvPr/>
+        </p:nvGraphicFramePr>
+        <p:xfrm>
+          <a:off x="457200" y="2743200"/>
+          <a:ext cx="8229600" cy="2743200"/>
+        </p:xfrm>
+        <a:graphic>
+          <a:graphicData uri="http://schemas.openxmlformats.org/drawingml/2006/table">
+            <a:tbl>
+              <a:tblPr firstRow="1" bandRow="1">
+                <a:tableStyleId>{5C22544A-7EE6-4342-B048-85BDC9FD1C3A}</a:tableStyleId>
+              </a:tblPr>
+              <a:tblGrid>
+                <a:gridCol w="1645920"/>
+                <a:gridCol w="1645920"/>
+                <a:gridCol w="1645920"/>
+                <a:gridCol w="1645920"/>
+                <a:gridCol w="1645920"/>
+              </a:tblGrid>
+              <a:tr h="304800">
+                <a:tc>
+                  <a:txBody>
+                    <a:bodyPr/>
+                    <a:lstStyle/>
+                    <a:p>
+                      <a:r>
+                        <a:rPr sz="1000"/>
+                        <a:t>Category</a:t>
+                      </a:r>
+                    </a:p>
+                  </a:txBody>
+                  <a:tcPr/>
+                </a:tc>
+                <a:tc>
+                  <a:txBody>
+                    <a:bodyPr/>
+                    <a:lstStyle/>
+                    <a:p>
+                      <a:r>
+                        <a:rPr sz="1000"/>
+                        <a:t>Own_Avg_Price</a:t>
+                      </a:r>
+                    </a:p>
+                  </a:txBody>
+                  <a:tcPr/>
+                </a:tc>
+                <a:tc>
+                  <a:txBody>
+                    <a:bodyPr/>
+                    <a:lstStyle/>
+                    <a:p>
+                      <a:r>
+                        <a:rPr sz="1000"/>
+                        <a:t>Market_Avg_Price</a:t>
+                      </a:r>
+                    </a:p>
+                  </a:txBody>
+                  <a:tcPr/>
+                </a:tc>
+                <a:tc>
+                  <a:txBody>
+                    <a:bodyPr/>
+                    <a:lstStyle/>
+                    <a:p>
+                      <a:r>
+                        <a:rPr sz="1000"/>
+                        <a:t>Price_Position</a:t>
+                      </a:r>
+                    </a:p>
+                  </a:txBody>
+                  <a:tcPr/>
+                </a:tc>
+                <a:tc>
+                  <a:txBody>
+                    <a:bodyPr/>
+                    <a:lstStyle/>
+                    <a:p>
+                      <a:r>
+                        <a:rPr sz="1000"/>
+                        <a:t>Market_Share_Pct</a:t>
+                      </a:r>
+                    </a:p>
+                  </a:txBody>
+                  <a:tcPr/>
+                </a:tc>
+              </a:tr>
+              <a:tr h="304800">
+                <a:tc>
+                  <a:txBody>
+                    <a:bodyPr/>
+                    <a:lstStyle/>
+                    <a:p>
+                      <a:r>
+                        <a:rPr sz="1000"/>
+                        <a:t>Audio</a:t>
+                      </a:r>
+                    </a:p>
+                  </a:txBody>
+                  <a:tcPr/>
+                </a:tc>
+                <a:tc>
+                  <a:txBody>
+                    <a:bodyPr/>
+                    <a:lstStyle/>
+                    <a:p>
+                      <a:r>
+                        <a:rPr sz="1000"/>
+                        <a:t>78.05</a:t>
+                      </a:r>
+                    </a:p>
+                  </a:txBody>
+                  <a:tcPr/>
+                </a:tc>
+                <a:tc>
+                  <a:txBody>
+                    <a:bodyPr/>
+                    <a:lstStyle/>
+                    <a:p>
+                      <a:r>
+                        <a:rPr sz="1000"/>
+                        <a:t>45</a:t>
+                      </a:r>
+                    </a:p>
+                  </a:txBody>
+                  <a:tcPr/>
+                </a:tc>
+                <a:tc>
+                  <a:txBody>
+                    <a:bodyPr/>
+                    <a:lstStyle/>
+                    <a:p>
+                      <a:r>
+                        <a:rPr sz="1000"/>
+                        <a:t>Premium</a:t>
+                      </a:r>
+                    </a:p>
+                  </a:txBody>
+                  <a:tcPr/>
+                </a:tc>
+                <a:tc>
+                  <a:txBody>
+                    <a:bodyPr/>
+                    <a:lstStyle/>
+                    <a:p>
+                      <a:r>
+                        <a:rPr sz="1000"/>
+                        <a:t>1.55</a:t>
+                      </a:r>
+                    </a:p>
+                  </a:txBody>
+                  <a:tcPr/>
+                </a:tc>
+              </a:tr>
+              <a:tr h="304800">
+                <a:tc>
+                  <a:txBody>
+                    <a:bodyPr/>
+                    <a:lstStyle/>
+                    <a:p>
+                      <a:r>
+                        <a:rPr sz="1000"/>
+                        <a:t>Cameras</a:t>
+                      </a:r>
+                    </a:p>
+                  </a:txBody>
+                  <a:tcPr/>
+                </a:tc>
+                <a:tc>
+                  <a:txBody>
+                    <a:bodyPr/>
+                    <a:lstStyle/>
+                    <a:p>
+                      <a:r>
+                        <a:rPr sz="1000"/>
+                        <a:t>23.91</a:t>
+                      </a:r>
+                    </a:p>
+                  </a:txBody>
+                  <a:tcPr/>
+                </a:tc>
+                <a:tc>
+                  <a:txBody>
+                    <a:bodyPr/>
+                    <a:lstStyle/>
+                    <a:p>
+                      <a:r>
+                        <a:rPr sz="1000"/>
+                        <a:t>350</a:t>
+                      </a:r>
+                    </a:p>
+                  </a:txBody>
+                  <a:tcPr/>
+                </a:tc>
+                <a:tc>
+                  <a:txBody>
+                    <a:bodyPr/>
+                    <a:lstStyle/>
+                    <a:p>
+                      <a:r>
+                        <a:rPr sz="1000"/>
+                        <a:t>Price Leader</a:t>
+                      </a:r>
+                    </a:p>
+                  </a:txBody>
+                  <a:tcPr/>
+                </a:tc>
+                <a:tc>
+                  <a:txBody>
+                    <a:bodyPr/>
+                    <a:lstStyle/>
+                    <a:p>
+                      <a:r>
+                        <a:rPr sz="1000"/>
+                        <a:t>0.39</a:t>
+                      </a:r>
+                    </a:p>
+                  </a:txBody>
+                  <a:tcPr/>
+                </a:tc>
+              </a:tr>
+              <a:tr h="304800">
+                <a:tc>
+                  <a:txBody>
+                    <a:bodyPr/>
+                    <a:lstStyle/>
+                    <a:p>
+                      <a:r>
+                        <a:rPr sz="1000"/>
+                        <a:t>Electronics</a:t>
+                      </a:r>
+                    </a:p>
+                  </a:txBody>
+                  <a:tcPr/>
+                </a:tc>
+                <a:tc>
+                  <a:txBody>
+                    <a:bodyPr/>
+                    <a:lstStyle/>
+                    <a:p>
+                      <a:r>
+                        <a:rPr sz="1000"/>
+                        <a:t>61.13</a:t>
+                      </a:r>
+                    </a:p>
+                  </a:txBody>
+                  <a:tcPr/>
+                </a:tc>
+                <a:tc>
+                  <a:txBody>
+                    <a:bodyPr/>
+                    <a:lstStyle/>
+                    <a:p>
+                      <a:r>
+                        <a:rPr sz="1000"/>
+                        <a:t>85</a:t>
+                      </a:r>
+                    </a:p>
+                  </a:txBody>
+                  <a:tcPr/>
+                </a:tc>
+                <a:tc>
+                  <a:txBody>
+                    <a:bodyPr/>
+                    <a:lstStyle/>
+                    <a:p>
+                      <a:r>
+                        <a:rPr sz="1000"/>
+                        <a:t>Price Leader</a:t>
+                      </a:r>
+                    </a:p>
+                  </a:txBody>
+                  <a:tcPr/>
+                </a:tc>
+                <a:tc>
+                  <a:txBody>
+                    <a:bodyPr/>
+                    <a:lstStyle/>
+                    <a:p>
+                      <a:r>
+                        <a:rPr sz="1000"/>
+                        <a:t>1.46</a:t>
+                      </a:r>
+                    </a:p>
+                  </a:txBody>
+                  <a:tcPr/>
+                </a:tc>
+              </a:tr>
+              <a:tr h="304800">
+                <a:tc>
+                  <a:txBody>
+                    <a:bodyPr/>
+                    <a:lstStyle/>
+                    <a:p>
+                      <a:r>
+                        <a:rPr sz="1000"/>
+                        <a:t>Headphones</a:t>
+                      </a:r>
+                    </a:p>
+                  </a:txBody>
+                  <a:tcPr/>
+                </a:tc>
+                <a:tc>
+                  <a:txBody>
+                    <a:bodyPr/>
+                    <a:lstStyle/>
+                    <a:p>
+                      <a:r>
+                        <a:rPr sz="1000"/>
+                        <a:t>49.49</a:t>
+                      </a:r>
+                    </a:p>
+                  </a:txBody>
+                  <a:tcPr/>
+                </a:tc>
+                <a:tc>
+                  <a:txBody>
+                    <a:bodyPr/>
+                    <a:lstStyle/>
+                    <a:p>
+                      <a:r>
+                        <a:rPr sz="1000"/>
+                        <a:t>75</a:t>
+                      </a:r>
+                    </a:p>
+                  </a:txBody>
+                  <a:tcPr/>
+                </a:tc>
+                <a:tc>
+                  <a:txBody>
+                    <a:bodyPr/>
+                    <a:lstStyle/>
+                    <a:p>
+                      <a:r>
+                        <a:rPr sz="1000"/>
+                        <a:t>Price Leader</a:t>
+                      </a:r>
+                    </a:p>
+                  </a:txBody>
+                  <a:tcPr/>
+                </a:tc>
+                <a:tc>
+                  <a:txBody>
+                    <a:bodyPr/>
+                    <a:lstStyle/>
+                    <a:p>
+                      <a:r>
+                        <a:rPr sz="1000"/>
+                        <a:t>1.24</a:t>
+                      </a:r>
+                    </a:p>
+                  </a:txBody>
+                  <a:tcPr/>
+                </a:tc>
+              </a:tr>
+              <a:tr h="304800">
+                <a:tc>
+                  <a:txBody>
+                    <a:bodyPr/>
+                    <a:lstStyle/>
+                    <a:p>
+                      <a:r>
+                        <a:rPr sz="1000"/>
+                        <a:t>Home Appliances</a:t>
+                      </a:r>
+                    </a:p>
+                  </a:txBody>
+                  <a:tcPr/>
+                </a:tc>
+                <a:tc>
+                  <a:txBody>
+                    <a:bodyPr/>
+                    <a:lstStyle/>
+                    <a:p>
+                      <a:r>
+                        <a:rPr sz="1000"/>
+                        <a:t>35.77</a:t>
+                      </a:r>
+                    </a:p>
+                  </a:txBody>
+                  <a:tcPr/>
+                </a:tc>
+                <a:tc>
+                  <a:txBody>
+                    <a:bodyPr/>
+                    <a:lstStyle/>
+                    <a:p>
+                      <a:r>
+                        <a:rPr sz="1000"/>
+                        <a:t>120</a:t>
+                      </a:r>
+                    </a:p>
+                  </a:txBody>
+                  <a:tcPr/>
+                </a:tc>
+                <a:tc>
+                  <a:txBody>
+                    <a:bodyPr/>
+                    <a:lstStyle/>
+                    <a:p>
+                      <a:r>
+                        <a:rPr sz="1000"/>
+                        <a:t>Price Leader</a:t>
+                      </a:r>
+                    </a:p>
+                  </a:txBody>
+                  <a:tcPr/>
+                </a:tc>
+                <a:tc>
+                  <a:txBody>
+                    <a:bodyPr/>
+                    <a:lstStyle/>
+                    <a:p>
+                      <a:r>
+                        <a:rPr sz="1000"/>
+                        <a:t>0.28</a:t>
+                      </a:r>
+                    </a:p>
+                  </a:txBody>
+                  <a:tcPr/>
+                </a:tc>
+              </a:tr>
+              <a:tr h="304800">
+                <a:tc>
+                  <a:txBody>
+                    <a:bodyPr/>
+                    <a:lstStyle/>
+                    <a:p>
+                      <a:r>
+                        <a:rPr sz="1000"/>
+                        <a:t>Speakers</a:t>
+                      </a:r>
+                    </a:p>
+                  </a:txBody>
+                  <a:tcPr/>
+                </a:tc>
+                <a:tc>
+                  <a:txBody>
+                    <a:bodyPr/>
+                    <a:lstStyle/>
+                    <a:p>
+                      <a:r>
+                        <a:rPr sz="1000"/>
+                        <a:t>135.16</a:t>
+                      </a:r>
+                    </a:p>
+                  </a:txBody>
+                  <a:tcPr/>
+                </a:tc>
+                <a:tc>
+                  <a:txBody>
+                    <a:bodyPr/>
+                    <a:lstStyle/>
+                    <a:p>
+                      <a:r>
+                        <a:rPr sz="1000"/>
+                        <a:t>90</a:t>
+                      </a:r>
+                    </a:p>
+                  </a:txBody>
+                  <a:tcPr/>
+                </a:tc>
+                <a:tc>
+                  <a:txBody>
+                    <a:bodyPr/>
+                    <a:lstStyle/>
+                    <a:p>
+                      <a:r>
+                        <a:rPr sz="1000"/>
+                        <a:t>Premium</a:t>
+                      </a:r>
+                    </a:p>
+                  </a:txBody>
+                  <a:tcPr/>
+                </a:tc>
+                <a:tc>
+                  <a:txBody>
+                    <a:bodyPr/>
+                    <a:lstStyle/>
+                    <a:p>
+                      <a:r>
+                        <a:rPr sz="1000"/>
+                        <a:t>1.55</a:t>
+                      </a:r>
+                    </a:p>
+                  </a:txBody>
+                  <a:tcPr/>
+                </a:tc>
+              </a:tr>
+              <a:tr h="304800">
+                <a:tc>
+                  <a:txBody>
+                    <a:bodyPr/>
+                    <a:lstStyle/>
+                    <a:p>
+                      <a:r>
+                        <a:rPr sz="1000"/>
+                        <a:t>TV &amp; Home Theater</a:t>
+                      </a:r>
+                    </a:p>
+                  </a:txBody>
+                  <a:tcPr/>
+                </a:tc>
+                <a:tc>
+                  <a:txBody>
+                    <a:bodyPr/>
+                    <a:lstStyle/>
+                    <a:p>
+                      <a:r>
+                        <a:rPr sz="1000"/>
+                        <a:t>304.9</a:t>
+                      </a:r>
+                    </a:p>
+                  </a:txBody>
+                  <a:tcPr/>
+                </a:tc>
+                <a:tc>
+                  <a:txBody>
+                    <a:bodyPr/>
+                    <a:lstStyle/>
+                    <a:p>
+                      <a:r>
+                        <a:rPr sz="1000"/>
+                        <a:t>450</a:t>
+                      </a:r>
+                    </a:p>
+                  </a:txBody>
+                  <a:tcPr/>
+                </a:tc>
+                <a:tc>
+                  <a:txBody>
+                    <a:bodyPr/>
+                    <a:lstStyle/>
+                    <a:p>
+                      <a:r>
+                        <a:rPr sz="1000"/>
+                        <a:t>Price Leader</a:t>
+                      </a:r>
+                    </a:p>
+                  </a:txBody>
+                  <a:tcPr/>
+                </a:tc>
+                <a:tc>
+                  <a:txBody>
+                    <a:bodyPr/>
+                    <a:lstStyle/>
+                    <a:p>
+                      <a:r>
+                        <a:rPr sz="1000"/>
+                        <a:t>4.14</a:t>
+                      </a:r>
+                    </a:p>
+                  </a:txBody>
+                  <a:tcPr/>
+                </a:tc>
+              </a:tr>
+              <a:tr h="304800">
+                <a:tc>
+                  <a:txBody>
+                    <a:bodyPr/>
+                    <a:lstStyle/>
+                    <a:p>
+                      <a:r>
+                        <a:rPr sz="1000"/>
+                        <a:t>Watches</a:t>
+                      </a:r>
+                    </a:p>
+                  </a:txBody>
+                  <a:tcPr/>
+                </a:tc>
+                <a:tc>
+                  <a:txBody>
+                    <a:bodyPr/>
+                    <a:lstStyle/>
+                    <a:p>
+                      <a:r>
+                        <a:rPr sz="1000"/>
+                        <a:t>60.69</a:t>
+                      </a:r>
+                    </a:p>
+                  </a:txBody>
+                  <a:tcPr/>
+                </a:tc>
+                <a:tc>
+                  <a:txBody>
+                    <a:bodyPr/>
+                    <a:lstStyle/>
+                    <a:p>
+                      <a:r>
+                        <a:rPr sz="1000"/>
+                        <a:t>55</a:t>
+                      </a:r>
+                    </a:p>
+                  </a:txBody>
+                  <a:tcPr/>
+                </a:tc>
+                <a:tc>
+                  <a:txBody>
+                    <a:bodyPr/>
+                    <a:lstStyle/>
+                    <a:p>
+                      <a:r>
+                        <a:rPr sz="1000"/>
+                        <a:t>Premium</a:t>
+                      </a:r>
+                    </a:p>
+                  </a:txBody>
+                  <a:tcPr/>
+                </a:tc>
+                <a:tc>
+                  <a:txBody>
+                    <a:bodyPr/>
+                    <a:lstStyle/>
+                    <a:p>
+                      <a:r>
+                        <a:rPr sz="1000"/>
+                        <a:t>0.83</a:t>
+                      </a:r>
+                    </a:p>
+                  </a:txBody>
+                  <a:tcPr/>
+                </a:tc>
+              </a:tr>
+            </a:tbl>
+          </a:graphicData>
+        </a:graphic>
+      </p:graphicFrame>
     </p:spTree>
   </p:cSld>
   <p:clrMapOvr>

</xml_diff>